<commit_message>
docs: URL del repositorio en el PDF para que baste con el documento
</commit_message>
<xml_diff>
--- a/docs/Responsa.pptx
+++ b/docs/Responsa.pptx
@@ -2246,7 +2246,7 @@
         </p:nvSpPr>
         <p:spPr>
           <a:xfrm>
-            <a:off x="777240" y="5230368"/>
+            <a:off x="777240" y="5047488"/>
             <a:ext cx="2743200" cy="237744"/>
           </a:xfrm>
           <a:prstGeom prst="rect">
@@ -2285,7 +2285,7 @@
         </p:nvSpPr>
         <p:spPr>
           <a:xfrm>
-            <a:off x="777240" y="5477256"/>
+            <a:off x="777240" y="5294376"/>
             <a:ext cx="5486400" cy="384048"/>
           </a:xfrm>
           <a:prstGeom prst="rect">
@@ -2324,6 +2324,45 @@
         </p:nvSpPr>
         <p:spPr>
           <a:xfrm>
+            <a:off x="777240" y="5760720"/>
+            <a:ext cx="5486400" cy="310896"/>
+          </a:xfrm>
+          <a:prstGeom prst="rect">
+            <a:avLst/>
+          </a:prstGeom>
+          <a:noFill/>
+          <a:ln/>
+        </p:spPr>
+        <p:txBody>
+          <a:bodyPr wrap="square" lIns="0" tIns="0" rIns="0" bIns="0" rtlCol="0" anchor="t"/>
+          <a:lstStyle/>
+          <a:p>
+            <a:pPr indent="0" marL="0">
+              <a:buNone/>
+            </a:pPr>
+            <a:r>
+              <a:rPr lang="en-US" sz="1300" b="1" dirty="0">
+                <a:solidFill>
+                  <a:srgbClr val="C9A574"/>
+                </a:solidFill>
+                <a:latin typeface="Courier New" pitchFamily="34" charset="0"/>
+                <a:ea typeface="Courier New" pitchFamily="34" charset="-122"/>
+                <a:cs typeface="Courier New" pitchFamily="34" charset="-120"/>
+              </a:rPr>
+              <a:t>github.com/djlarrix/Responsa</a:t>
+            </a:r>
+            <a:endParaRPr lang="en-US" sz="1300" dirty="0"/>
+          </a:p>
+        </p:txBody>
+      </p:sp>
+      <p:sp>
+        <p:nvSpPr>
+          <p:cNvPr id="8" name="Text 6"/>
+          <p:cNvSpPr/>
+          <p:nvPr/>
+        </p:nvSpPr>
+        <p:spPr>
+          <a:xfrm>
             <a:off x="5669280" y="658368"/>
             <a:ext cx="5852160" cy="822960"/>
           </a:xfrm>
@@ -2357,7 +2396,7 @@
       </p:sp>
       <p:sp>
         <p:nvSpPr>
-          <p:cNvPr id="8" name="Shape 6"/>
+          <p:cNvPr id="9" name="Shape 7"/>
           <p:cNvSpPr/>
           <p:nvPr/>
         </p:nvSpPr>
@@ -2377,7 +2416,7 @@
       </p:sp>
       <p:sp>
         <p:nvSpPr>
-          <p:cNvPr id="9" name="Text 7"/>
+          <p:cNvPr id="10" name="Text 8"/>
           <p:cNvSpPr/>
           <p:nvPr/>
         </p:nvSpPr>
@@ -3212,7 +3251,7 @@
                 <a:ea typeface="Calibri" pitchFamily="34" charset="-122"/>
                 <a:cs typeface="Calibri" pitchFamily="34" charset="-120"/>
               </a:rPr>
-              <a:t>Abre la terminal, pega la línea que corresponde a tu sistema y pulsa Enter</a:t>
+              <a:t>Abre la terminal, pega la línea que corresponde a tu sistema y pulsa Enter. El texto de este PDF se puede copiar</a:t>
             </a:r>
             <a:endParaRPr lang="en-US" sz="1350" dirty="0"/>
           </a:p>
@@ -3937,7 +3976,7 @@
                 <a:ea typeface="Calibri" pitchFamily="34" charset="-122"/>
                 <a:cs typeface="Calibri" pitchFamily="34" charset="-120"/>
               </a:rPr>
-              <a:t>Se puede ejecutar las veces que haga falta: si ya está instalado, actualiza.</a:t>
+              <a:t>Se puede ejecutar las veces que haga falta: si ya está instalado, actualiza.   ·   Repositorio: github.com/djlarrix/Responsa</a:t>
             </a:r>
             <a:endParaRPr lang="en-US" sz="1050" dirty="0"/>
           </a:p>

</xml_diff>

<commit_message>
﻿Aviso de cerrar Claude Desktop antes de instalar
</commit_message>
<xml_diff>
--- a/docs/Responsa.pptx
+++ b/docs/Responsa.pptx
@@ -3251,7 +3251,7 @@
                 <a:ea typeface="Calibri" pitchFamily="34" charset="-122"/>
                 <a:cs typeface="Calibri" pitchFamily="34" charset="-120"/>
               </a:rPr>
-              <a:t>Abre la terminal, pega la línea que corresponde a tu sistema y pulsa Enter. El texto de este PDF se puede copiar</a:t>
+              <a:t>Antes de empezar, cierra Claude Desktop por completo. El texto de este PDF se puede copiar</a:t>
             </a:r>
             <a:endParaRPr lang="en-US" sz="1350" dirty="0"/>
           </a:p>
@@ -3265,7 +3265,68 @@
         </p:nvSpPr>
         <p:spPr>
           <a:xfrm>
-            <a:off x="777240" y="1828800"/>
+            <a:off x="777240" y="1664208"/>
+            <a:ext cx="10634472" cy="457200"/>
+          </a:xfrm>
+          <a:prstGeom prst="roundRect">
+            <a:avLst>
+              <a:gd name="adj" fmla="val 10000"/>
+            </a:avLst>
+          </a:prstGeom>
+          <a:solidFill>
+            <a:srgbClr val="FDF7E8"/>
+          </a:solidFill>
+          <a:ln/>
+        </p:spPr>
+      </p:sp>
+      <p:sp>
+        <p:nvSpPr>
+          <p:cNvPr id="5" name="Text 3"/>
+          <p:cNvSpPr/>
+          <p:nvPr/>
+        </p:nvSpPr>
+        <p:spPr>
+          <a:xfrm>
+            <a:off x="1033272" y="1664208"/>
+            <a:ext cx="10149840" cy="457200"/>
+          </a:xfrm>
+          <a:prstGeom prst="rect">
+            <a:avLst/>
+          </a:prstGeom>
+          <a:noFill/>
+          <a:ln/>
+        </p:spPr>
+        <p:txBody>
+          <a:bodyPr wrap="square" lIns="0" tIns="0" rIns="0" bIns="0" rtlCol="0" anchor="ctr"/>
+          <a:lstStyle/>
+          <a:p>
+            <a:pPr indent="0" marL="0">
+              <a:buNone/>
+            </a:pPr>
+            <a:r>
+              <a:rPr lang="en-US" sz="1100" b="1" dirty="0">
+                <a:solidFill>
+                  <a:srgbClr val="6B2C33"/>
+                </a:solidFill>
+                <a:latin typeface="Calibri" pitchFamily="34" charset="0"/>
+                <a:ea typeface="Calibri" pitchFamily="34" charset="-122"/>
+                <a:cs typeface="Calibri" pitchFamily="34" charset="-120"/>
+              </a:rPr>
+              <a:t>Claude Desktop tiene que estar CERRADO. Al cerrarse sobrescribe su configuración, así que si está abierto la instalación no queda.</a:t>
+            </a:r>
+            <a:endParaRPr lang="en-US" sz="1100" dirty="0"/>
+          </a:p>
+        </p:txBody>
+      </p:sp>
+      <p:sp>
+        <p:nvSpPr>
+          <p:cNvPr id="6" name="Shape 4"/>
+          <p:cNvSpPr/>
+          <p:nvPr/>
+        </p:nvSpPr>
+        <p:spPr>
+          <a:xfrm>
+            <a:off x="777240" y="2286000"/>
             <a:ext cx="1051560" cy="274320"/>
           </a:xfrm>
           <a:prstGeom prst="roundRect">
@@ -3281,13 +3342,13 @@
       </p:sp>
       <p:sp>
         <p:nvSpPr>
-          <p:cNvPr id="5" name="Text 3"/>
-          <p:cNvSpPr/>
-          <p:nvPr/>
-        </p:nvSpPr>
-        <p:spPr>
-          <a:xfrm>
-            <a:off x="777240" y="1828800"/>
+          <p:cNvPr id="7" name="Text 5"/>
+          <p:cNvSpPr/>
+          <p:nvPr/>
+        </p:nvSpPr>
+        <p:spPr>
+          <a:xfrm>
+            <a:off x="777240" y="2286000"/>
             <a:ext cx="1051560" cy="274320"/>
           </a:xfrm>
           <a:prstGeom prst="rect">
@@ -3320,13 +3381,13 @@
       </p:sp>
       <p:sp>
         <p:nvSpPr>
-          <p:cNvPr id="6" name="Text 4"/>
-          <p:cNvSpPr/>
-          <p:nvPr/>
-        </p:nvSpPr>
-        <p:spPr>
-          <a:xfrm>
-            <a:off x="1965960" y="1847088"/>
+          <p:cNvPr id="8" name="Text 6"/>
+          <p:cNvSpPr/>
+          <p:nvPr/>
+        </p:nvSpPr>
+        <p:spPr>
+          <a:xfrm>
+            <a:off x="1965960" y="2304288"/>
             <a:ext cx="4572000" cy="256032"/>
           </a:xfrm>
           <a:prstGeom prst="rect">
@@ -3359,18 +3420,18 @@
       </p:sp>
       <p:sp>
         <p:nvSpPr>
-          <p:cNvPr id="7" name="Shape 5"/>
-          <p:cNvSpPr/>
-          <p:nvPr/>
-        </p:nvSpPr>
-        <p:spPr>
-          <a:xfrm>
-            <a:off x="777240" y="2212848"/>
-            <a:ext cx="10634472" cy="603504"/>
+          <p:cNvPr id="9" name="Shape 7"/>
+          <p:cNvSpPr/>
+          <p:nvPr/>
+        </p:nvSpPr>
+        <p:spPr>
+          <a:xfrm>
+            <a:off x="777240" y="2670048"/>
+            <a:ext cx="10634472" cy="566928"/>
           </a:xfrm>
           <a:prstGeom prst="roundRect">
             <a:avLst>
-              <a:gd name="adj" fmla="val 7576"/>
+              <a:gd name="adj" fmla="val 8065"/>
             </a:avLst>
           </a:prstGeom>
           <a:solidFill>
@@ -3381,14 +3442,14 @@
       </p:sp>
       <p:sp>
         <p:nvSpPr>
-          <p:cNvPr id="8" name="Text 6"/>
-          <p:cNvSpPr/>
-          <p:nvPr/>
-        </p:nvSpPr>
-        <p:spPr>
-          <a:xfrm>
-            <a:off x="996696" y="2212848"/>
-            <a:ext cx="10195560" cy="603504"/>
+          <p:cNvPr id="10" name="Text 8"/>
+          <p:cNvSpPr/>
+          <p:nvPr/>
+        </p:nvSpPr>
+        <p:spPr>
+          <a:xfrm>
+            <a:off x="996696" y="2670048"/>
+            <a:ext cx="10195560" cy="566928"/>
           </a:xfrm>
           <a:prstGeom prst="rect">
             <a:avLst/>
@@ -3420,13 +3481,13 @@
       </p:sp>
       <p:sp>
         <p:nvSpPr>
-          <p:cNvPr id="9" name="Shape 7"/>
-          <p:cNvSpPr/>
-          <p:nvPr/>
-        </p:nvSpPr>
-        <p:spPr>
-          <a:xfrm>
-            <a:off x="777240" y="3054096"/>
+          <p:cNvPr id="11" name="Shape 9"/>
+          <p:cNvSpPr/>
+          <p:nvPr/>
+        </p:nvSpPr>
+        <p:spPr>
+          <a:xfrm>
+            <a:off x="777240" y="3474720"/>
             <a:ext cx="1051560" cy="274320"/>
           </a:xfrm>
           <a:prstGeom prst="roundRect">
@@ -3442,13 +3503,13 @@
       </p:sp>
       <p:sp>
         <p:nvSpPr>
-          <p:cNvPr id="10" name="Text 8"/>
-          <p:cNvSpPr/>
-          <p:nvPr/>
-        </p:nvSpPr>
-        <p:spPr>
-          <a:xfrm>
-            <a:off x="777240" y="3054096"/>
+          <p:cNvPr id="12" name="Text 10"/>
+          <p:cNvSpPr/>
+          <p:nvPr/>
+        </p:nvSpPr>
+        <p:spPr>
+          <a:xfrm>
+            <a:off x="777240" y="3474720"/>
             <a:ext cx="1051560" cy="274320"/>
           </a:xfrm>
           <a:prstGeom prst="rect">
@@ -3481,13 +3542,13 @@
       </p:sp>
       <p:sp>
         <p:nvSpPr>
-          <p:cNvPr id="11" name="Text 9"/>
-          <p:cNvSpPr/>
-          <p:nvPr/>
-        </p:nvSpPr>
-        <p:spPr>
-          <a:xfrm>
-            <a:off x="1965960" y="3072384"/>
+          <p:cNvPr id="13" name="Text 11"/>
+          <p:cNvSpPr/>
+          <p:nvPr/>
+        </p:nvSpPr>
+        <p:spPr>
+          <a:xfrm>
+            <a:off x="1965960" y="3493008"/>
             <a:ext cx="4572000" cy="256032"/>
           </a:xfrm>
           <a:prstGeom prst="rect">
@@ -3520,18 +3581,18 @@
       </p:sp>
       <p:sp>
         <p:nvSpPr>
-          <p:cNvPr id="12" name="Shape 10"/>
-          <p:cNvSpPr/>
-          <p:nvPr/>
-        </p:nvSpPr>
-        <p:spPr>
-          <a:xfrm>
-            <a:off x="777240" y="3438144"/>
-            <a:ext cx="10634472" cy="603504"/>
+          <p:cNvPr id="14" name="Shape 12"/>
+          <p:cNvSpPr/>
+          <p:nvPr/>
+        </p:nvSpPr>
+        <p:spPr>
+          <a:xfrm>
+            <a:off x="777240" y="3858768"/>
+            <a:ext cx="10634472" cy="566928"/>
           </a:xfrm>
           <a:prstGeom prst="roundRect">
             <a:avLst>
-              <a:gd name="adj" fmla="val 7576"/>
+              <a:gd name="adj" fmla="val 8065"/>
             </a:avLst>
           </a:prstGeom>
           <a:solidFill>
@@ -3542,14 +3603,14 @@
       </p:sp>
       <p:sp>
         <p:nvSpPr>
-          <p:cNvPr id="13" name="Text 11"/>
-          <p:cNvSpPr/>
-          <p:nvPr/>
-        </p:nvSpPr>
-        <p:spPr>
-          <a:xfrm>
-            <a:off x="996696" y="3438144"/>
-            <a:ext cx="10195560" cy="603504"/>
+          <p:cNvPr id="15" name="Text 13"/>
+          <p:cNvSpPr/>
+          <p:nvPr/>
+        </p:nvSpPr>
+        <p:spPr>
+          <a:xfrm>
+            <a:off x="996696" y="3858768"/>
+            <a:ext cx="10195560" cy="566928"/>
           </a:xfrm>
           <a:prstGeom prst="rect">
             <a:avLst/>
@@ -3581,18 +3642,18 @@
       </p:sp>
       <p:sp>
         <p:nvSpPr>
-          <p:cNvPr id="14" name="Shape 12"/>
-          <p:cNvSpPr/>
-          <p:nvPr/>
-        </p:nvSpPr>
-        <p:spPr>
-          <a:xfrm>
-            <a:off x="777240" y="4315968"/>
-            <a:ext cx="5120640" cy="1783080"/>
+          <p:cNvPr id="16" name="Shape 14"/>
+          <p:cNvSpPr/>
+          <p:nvPr/>
+        </p:nvSpPr>
+        <p:spPr>
+          <a:xfrm>
+            <a:off x="777240" y="4626864"/>
+            <a:ext cx="5120640" cy="1517904"/>
           </a:xfrm>
           <a:prstGeom prst="roundRect">
             <a:avLst>
-              <a:gd name="adj" fmla="val 3077"/>
+              <a:gd name="adj" fmla="val 3614"/>
             </a:avLst>
           </a:prstGeom>
           <a:solidFill>
@@ -3608,13 +3669,13 @@
       </p:sp>
       <p:sp>
         <p:nvSpPr>
-          <p:cNvPr id="15" name="Text 13"/>
-          <p:cNvSpPr/>
-          <p:nvPr/>
-        </p:nvSpPr>
-        <p:spPr>
-          <a:xfrm>
-            <a:off x="1069848" y="4517136"/>
+          <p:cNvPr id="17" name="Text 15"/>
+          <p:cNvSpPr/>
+          <p:nvPr/>
+        </p:nvSpPr>
+        <p:spPr>
+          <a:xfrm>
+            <a:off x="1069848" y="4791456"/>
             <a:ext cx="4480560" cy="256032"/>
           </a:xfrm>
           <a:prstGeom prst="rect">
@@ -3647,13 +3708,13 @@
       </p:sp>
       <p:sp>
         <p:nvSpPr>
-          <p:cNvPr id="16" name="Text 14"/>
-          <p:cNvSpPr/>
-          <p:nvPr/>
-        </p:nvSpPr>
-        <p:spPr>
-          <a:xfrm>
-            <a:off x="1069848" y="4846320"/>
+          <p:cNvPr id="18" name="Text 16"/>
+          <p:cNvSpPr/>
+          <p:nvPr/>
+        </p:nvSpPr>
+        <p:spPr>
+          <a:xfrm>
+            <a:off x="1069848" y="5102352"/>
             <a:ext cx="4572000" cy="274320"/>
           </a:xfrm>
           <a:prstGeom prst="rect">
@@ -3686,13 +3747,13 @@
       </p:sp>
       <p:sp>
         <p:nvSpPr>
-          <p:cNvPr id="17" name="Text 15"/>
-          <p:cNvSpPr/>
-          <p:nvPr/>
-        </p:nvSpPr>
-        <p:spPr>
-          <a:xfrm>
-            <a:off x="1069848" y="5148072"/>
+          <p:cNvPr id="19" name="Text 17"/>
+          <p:cNvSpPr/>
+          <p:nvPr/>
+        </p:nvSpPr>
+        <p:spPr>
+          <a:xfrm>
+            <a:off x="1069848" y="5376672"/>
             <a:ext cx="4572000" cy="274320"/>
           </a:xfrm>
           <a:prstGeom prst="rect">
@@ -3725,13 +3786,13 @@
       </p:sp>
       <p:sp>
         <p:nvSpPr>
-          <p:cNvPr id="18" name="Text 16"/>
-          <p:cNvSpPr/>
-          <p:nvPr/>
-        </p:nvSpPr>
-        <p:spPr>
-          <a:xfrm>
-            <a:off x="1069848" y="5449824"/>
+          <p:cNvPr id="20" name="Text 18"/>
+          <p:cNvSpPr/>
+          <p:nvPr/>
+        </p:nvSpPr>
+        <p:spPr>
+          <a:xfrm>
+            <a:off x="1069848" y="5650992"/>
             <a:ext cx="4572000" cy="274320"/>
           </a:xfrm>
           <a:prstGeom prst="rect">
@@ -3764,13 +3825,13 @@
       </p:sp>
       <p:sp>
         <p:nvSpPr>
-          <p:cNvPr id="19" name="Text 17"/>
-          <p:cNvSpPr/>
-          <p:nvPr/>
-        </p:nvSpPr>
-        <p:spPr>
-          <a:xfrm>
-            <a:off x="1069848" y="5751576"/>
+          <p:cNvPr id="21" name="Text 19"/>
+          <p:cNvSpPr/>
+          <p:nvPr/>
+        </p:nvSpPr>
+        <p:spPr>
+          <a:xfrm>
+            <a:off x="1069848" y="5925312"/>
             <a:ext cx="4572000" cy="274320"/>
           </a:xfrm>
           <a:prstGeom prst="rect">
@@ -3803,18 +3864,18 @@
       </p:sp>
       <p:sp>
         <p:nvSpPr>
-          <p:cNvPr id="20" name="Shape 18"/>
-          <p:cNvSpPr/>
-          <p:nvPr/>
-        </p:nvSpPr>
-        <p:spPr>
-          <a:xfrm>
-            <a:off x="6263640" y="4315968"/>
-            <a:ext cx="5148072" cy="1783080"/>
+          <p:cNvPr id="22" name="Shape 20"/>
+          <p:cNvSpPr/>
+          <p:nvPr/>
+        </p:nvSpPr>
+        <p:spPr>
+          <a:xfrm>
+            <a:off x="6263640" y="4626864"/>
+            <a:ext cx="5148072" cy="1517904"/>
           </a:xfrm>
           <a:prstGeom prst="roundRect">
             <a:avLst>
-              <a:gd name="adj" fmla="val 3077"/>
+              <a:gd name="adj" fmla="val 3614"/>
             </a:avLst>
           </a:prstGeom>
           <a:solidFill>
@@ -3825,13 +3886,13 @@
       </p:sp>
       <p:sp>
         <p:nvSpPr>
-          <p:cNvPr id="21" name="Text 19"/>
-          <p:cNvSpPr/>
-          <p:nvPr/>
-        </p:nvSpPr>
-        <p:spPr>
-          <a:xfrm>
-            <a:off x="6583680" y="4517136"/>
+          <p:cNvPr id="23" name="Text 21"/>
+          <p:cNvSpPr/>
+          <p:nvPr/>
+        </p:nvSpPr>
+        <p:spPr>
+          <a:xfrm>
+            <a:off x="6583680" y="4791456"/>
             <a:ext cx="4480560" cy="256032"/>
           </a:xfrm>
           <a:prstGeom prst="rect">
@@ -3864,13 +3925,13 @@
       </p:sp>
       <p:sp>
         <p:nvSpPr>
-          <p:cNvPr id="22" name="Text 20"/>
-          <p:cNvSpPr/>
-          <p:nvPr/>
-        </p:nvSpPr>
-        <p:spPr>
-          <a:xfrm>
-            <a:off x="6583680" y="4828032"/>
+          <p:cNvPr id="24" name="Text 22"/>
+          <p:cNvSpPr/>
+          <p:nvPr/>
+        </p:nvSpPr>
+        <p:spPr>
+          <a:xfrm>
+            <a:off x="6583680" y="5084064"/>
             <a:ext cx="4480560" cy="822960"/>
           </a:xfrm>
           <a:prstGeom prst="rect">
@@ -3906,13 +3967,13 @@
       </p:sp>
       <p:sp>
         <p:nvSpPr>
-          <p:cNvPr id="23" name="Text 21"/>
-          <p:cNvSpPr/>
-          <p:nvPr/>
-        </p:nvSpPr>
-        <p:spPr>
-          <a:xfrm>
-            <a:off x="6583680" y="5687568"/>
+          <p:cNvPr id="25" name="Text 23"/>
+          <p:cNvSpPr/>
+          <p:nvPr/>
+        </p:nvSpPr>
+        <p:spPr>
+          <a:xfrm>
+            <a:off x="6583680" y="5852160"/>
             <a:ext cx="4480560" cy="292608"/>
           </a:xfrm>
           <a:prstGeom prst="rect">
@@ -3945,13 +4006,13 @@
       </p:sp>
       <p:sp>
         <p:nvSpPr>
-          <p:cNvPr id="24" name="Text 22"/>
-          <p:cNvSpPr/>
-          <p:nvPr/>
-        </p:nvSpPr>
-        <p:spPr>
-          <a:xfrm>
-            <a:off x="777240" y="6236208"/>
+          <p:cNvPr id="26" name="Text 24"/>
+          <p:cNvSpPr/>
+          <p:nvPr/>
+        </p:nvSpPr>
+        <p:spPr>
+          <a:xfrm>
+            <a:off x="777240" y="6327648"/>
             <a:ext cx="10634472" cy="365760"/>
           </a:xfrm>
           <a:prstGeom prst="rect">

</xml_diff>

<commit_message>
Presentación al día: 21 herramientas y los dos ejemplos nuevos
Añade a la lámina de ejemplos el pronóstico judicial ("¿qué tan posible es
que prospere este despido?", que busca jurisprudencia aunque no se la nombren)
y la carpeta de respaldo. Con nueve ejemplos el interlineado de siete se
desbordaba sobre el pie de lámina, así que se ajustó a 0,53.

Co-Authored-By: Claude Opus 5 <noreply@anthropic.com>
</commit_message>
<xml_diff>
--- a/docs/Responsa.pptx
+++ b/docs/Responsa.pptx
@@ -6611,7 +6611,7 @@
                 <a:ea typeface="Cambria" pitchFamily="34" charset="-122"/>
                 <a:cs typeface="Cambria" pitchFamily="34" charset="-120"/>
               </a:rPr>
-              <a:t>20</a:t>
+              <a:t>21</a:t>
             </a:r>
             <a:endParaRPr lang="en-US" sz="5200" dirty="0"/>
           </a:p>
@@ -12568,7 +12568,7 @@
                 <a:ea typeface="Calibri" pitchFamily="34" charset="-122"/>
                 <a:cs typeface="Calibri" pitchFamily="34" charset="-120"/>
               </a:rPr>
-              <a:t>Entre las veinte herramientas disponibles, selecciona las que corresponden. Una consulta puede combinar varias: ubicar la norma, leer su texto, traer los fallos y sumar el criterio administrativo.</a:t>
+              <a:t>Entre las veintiuna herramientas disponibles, selecciona las que corresponden. Una consulta puede combinar varias: ubicar la norma, leer su texto, traer los fallos y sumar el criterio administrativo.</a:t>
             </a:r>
             <a:endParaRPr lang="en-US" sz="1050" dirty="0"/>
           </a:p>
@@ -13764,7 +13764,7 @@
         </p:nvSpPr>
         <p:spPr>
           <a:xfrm>
-            <a:off x="777240" y="1755648"/>
+            <a:off x="777240" y="1645920"/>
             <a:ext cx="6309360" cy="310896"/>
           </a:xfrm>
           <a:prstGeom prst="rect">
@@ -13803,7 +13803,7 @@
         </p:nvSpPr>
         <p:spPr>
           <a:xfrm>
-            <a:off x="7269480" y="1792224"/>
+            <a:off x="7269480" y="1682496"/>
             <a:ext cx="4114800" cy="274320"/>
           </a:xfrm>
           <a:prstGeom prst="rect">
@@ -13842,7 +13842,7 @@
         </p:nvSpPr>
         <p:spPr>
           <a:xfrm>
-            <a:off x="777240" y="2377440"/>
+            <a:off x="777240" y="2130552"/>
             <a:ext cx="6309360" cy="310896"/>
           </a:xfrm>
           <a:prstGeom prst="rect">
@@ -13881,7 +13881,7 @@
         </p:nvSpPr>
         <p:spPr>
           <a:xfrm>
-            <a:off x="7269480" y="2414016"/>
+            <a:off x="7269480" y="2167128"/>
             <a:ext cx="4114800" cy="274320"/>
           </a:xfrm>
           <a:prstGeom prst="rect">
@@ -13920,7 +13920,7 @@
         </p:nvSpPr>
         <p:spPr>
           <a:xfrm>
-            <a:off x="777240" y="2999232"/>
+            <a:off x="777240" y="2615184"/>
             <a:ext cx="6309360" cy="310896"/>
           </a:xfrm>
           <a:prstGeom prst="rect">
@@ -13959,7 +13959,7 @@
         </p:nvSpPr>
         <p:spPr>
           <a:xfrm>
-            <a:off x="7269480" y="3035808"/>
+            <a:off x="7269480" y="2651760"/>
             <a:ext cx="4114800" cy="274320"/>
           </a:xfrm>
           <a:prstGeom prst="rect">
@@ -13998,7 +13998,7 @@
         </p:nvSpPr>
         <p:spPr>
           <a:xfrm>
-            <a:off x="777240" y="3621024"/>
+            <a:off x="777240" y="3099816"/>
             <a:ext cx="6309360" cy="310896"/>
           </a:xfrm>
           <a:prstGeom prst="rect">
@@ -14037,7 +14037,7 @@
         </p:nvSpPr>
         <p:spPr>
           <a:xfrm>
-            <a:off x="7269480" y="3657600"/>
+            <a:off x="7269480" y="3136392"/>
             <a:ext cx="4114800" cy="274320"/>
           </a:xfrm>
           <a:prstGeom prst="rect">
@@ -14076,7 +14076,7 @@
         </p:nvSpPr>
         <p:spPr>
           <a:xfrm>
-            <a:off x="777240" y="4242816"/>
+            <a:off x="777240" y="3584448"/>
             <a:ext cx="6309360" cy="310896"/>
           </a:xfrm>
           <a:prstGeom prst="rect">
@@ -14115,7 +14115,7 @@
         </p:nvSpPr>
         <p:spPr>
           <a:xfrm>
-            <a:off x="7269480" y="4279392"/>
+            <a:off x="7269480" y="3621024"/>
             <a:ext cx="4114800" cy="274320"/>
           </a:xfrm>
           <a:prstGeom prst="rect">
@@ -14154,7 +14154,7 @@
         </p:nvSpPr>
         <p:spPr>
           <a:xfrm>
-            <a:off x="777240" y="4864608"/>
+            <a:off x="777240" y="4069080"/>
             <a:ext cx="6309360" cy="310896"/>
           </a:xfrm>
           <a:prstGeom prst="rect">
@@ -14193,7 +14193,7 @@
         </p:nvSpPr>
         <p:spPr>
           <a:xfrm>
-            <a:off x="7269480" y="4901184"/>
+            <a:off x="7269480" y="4105656"/>
             <a:ext cx="4114800" cy="274320"/>
           </a:xfrm>
           <a:prstGeom prst="rect">
@@ -14232,7 +14232,7 @@
         </p:nvSpPr>
         <p:spPr>
           <a:xfrm>
-            <a:off x="777240" y="5486400"/>
+            <a:off x="777240" y="4553712"/>
             <a:ext cx="6309360" cy="310896"/>
           </a:xfrm>
           <a:prstGeom prst="rect">
@@ -14271,7 +14271,7 @@
         </p:nvSpPr>
         <p:spPr>
           <a:xfrm>
-            <a:off x="7269480" y="5522976"/>
+            <a:off x="7269480" y="4590288"/>
             <a:ext cx="4114800" cy="274320"/>
           </a:xfrm>
           <a:prstGeom prst="rect">
@@ -14305,6 +14305,162 @@
       <p:sp>
         <p:nvSpPr>
           <p:cNvPr id="18" name="Text 16"/>
+          <p:cNvSpPr/>
+          <p:nvPr/>
+        </p:nvSpPr>
+        <p:spPr>
+          <a:xfrm>
+            <a:off x="777240" y="5038344"/>
+            <a:ext cx="6309360" cy="310896"/>
+          </a:xfrm>
+          <a:prstGeom prst="rect">
+            <a:avLst/>
+          </a:prstGeom>
+          <a:noFill/>
+          <a:ln/>
+        </p:spPr>
+        <p:txBody>
+          <a:bodyPr wrap="square" lIns="0" tIns="0" rIns="0" bIns="0" rtlCol="0" anchor="ctr"/>
+          <a:lstStyle/>
+          <a:p>
+            <a:pPr indent="0" marL="0">
+              <a:buNone/>
+            </a:pPr>
+            <a:r>
+              <a:rPr lang="en-US" sz="1450" dirty="0">
+                <a:solidFill>
+                  <a:srgbClr val="FFFFFF"/>
+                </a:solidFill>
+                <a:latin typeface="Cambria" pitchFamily="34" charset="0"/>
+                <a:ea typeface="Cambria" pitchFamily="34" charset="-122"/>
+                <a:cs typeface="Cambria" pitchFamily="34" charset="-120"/>
+              </a:rPr>
+              <a:t>«¿Qué tan posible es que prospere este despido?»</a:t>
+            </a:r>
+            <a:endParaRPr lang="en-US" sz="1450" dirty="0"/>
+          </a:p>
+        </p:txBody>
+      </p:sp>
+      <p:sp>
+        <p:nvSpPr>
+          <p:cNvPr id="19" name="Text 17"/>
+          <p:cNvSpPr/>
+          <p:nvPr/>
+        </p:nvSpPr>
+        <p:spPr>
+          <a:xfrm>
+            <a:off x="7269480" y="5074920"/>
+            <a:ext cx="4114800" cy="274320"/>
+          </a:xfrm>
+          <a:prstGeom prst="rect">
+            <a:avLst/>
+          </a:prstGeom>
+          <a:noFill/>
+          <a:ln/>
+        </p:spPr>
+        <p:txBody>
+          <a:bodyPr wrap="square" lIns="0" tIns="0" rIns="0" bIns="0" rtlCol="0" anchor="ctr"/>
+          <a:lstStyle/>
+          <a:p>
+            <a:pPr indent="0" marL="0">
+              <a:buNone/>
+            </a:pPr>
+            <a:r>
+              <a:rPr lang="en-US" sz="1050" dirty="0">
+                <a:solidFill>
+                  <a:srgbClr val="C9A574"/>
+                </a:solidFill>
+                <a:latin typeface="Calibri" pitchFamily="34" charset="0"/>
+                <a:ea typeface="Calibri" pitchFamily="34" charset="-122"/>
+                <a:cs typeface="Calibri" pitchFamily="34" charset="-120"/>
+              </a:rPr>
+              <a:t>Busca jurisprudencia aunque no se la nombren</a:t>
+            </a:r>
+            <a:endParaRPr lang="en-US" sz="1050" dirty="0"/>
+          </a:p>
+        </p:txBody>
+      </p:sp>
+      <p:sp>
+        <p:nvSpPr>
+          <p:cNvPr id="20" name="Text 18"/>
+          <p:cNvSpPr/>
+          <p:nvPr/>
+        </p:nvSpPr>
+        <p:spPr>
+          <a:xfrm>
+            <a:off x="777240" y="5522976"/>
+            <a:ext cx="6309360" cy="310896"/>
+          </a:xfrm>
+          <a:prstGeom prst="rect">
+            <a:avLst/>
+          </a:prstGeom>
+          <a:noFill/>
+          <a:ln/>
+        </p:spPr>
+        <p:txBody>
+          <a:bodyPr wrap="square" lIns="0" tIns="0" rIns="0" bIns="0" rtlCol="0" anchor="ctr"/>
+          <a:lstStyle/>
+          <a:p>
+            <a:pPr indent="0" marL="0">
+              <a:buNone/>
+            </a:pPr>
+            <a:r>
+              <a:rPr lang="en-US" sz="1450" dirty="0">
+                <a:solidFill>
+                  <a:srgbClr val="FFFFFF"/>
+                </a:solidFill>
+                <a:latin typeface="Cambria" pitchFamily="34" charset="0"/>
+                <a:ea typeface="Cambria" pitchFamily="34" charset="-122"/>
+                <a:cs typeface="Cambria" pitchFamily="34" charset="-120"/>
+              </a:rPr>
+              <a:t>«Déjame los documentos en una carpeta»</a:t>
+            </a:r>
+            <a:endParaRPr lang="en-US" sz="1450" dirty="0"/>
+          </a:p>
+        </p:txBody>
+      </p:sp>
+      <p:sp>
+        <p:nvSpPr>
+          <p:cNvPr id="21" name="Text 19"/>
+          <p:cNvSpPr/>
+          <p:nvPr/>
+        </p:nvSpPr>
+        <p:spPr>
+          <a:xfrm>
+            <a:off x="7269480" y="5559552"/>
+            <a:ext cx="4114800" cy="274320"/>
+          </a:xfrm>
+          <a:prstGeom prst="rect">
+            <a:avLst/>
+          </a:prstGeom>
+          <a:noFill/>
+          <a:ln/>
+        </p:spPr>
+        <p:txBody>
+          <a:bodyPr wrap="square" lIns="0" tIns="0" rIns="0" bIns="0" rtlCol="0" anchor="ctr"/>
+          <a:lstStyle/>
+          <a:p>
+            <a:pPr indent="0" marL="0">
+              <a:buNone/>
+            </a:pPr>
+            <a:r>
+              <a:rPr lang="en-US" sz="1050" dirty="0">
+                <a:solidFill>
+                  <a:srgbClr val="C9A574"/>
+                </a:solidFill>
+                <a:latin typeface="Calibri" pitchFamily="34" charset="0"/>
+                <a:ea typeface="Calibri" pitchFamily="34" charset="-122"/>
+                <a:cs typeface="Calibri" pitchFamily="34" charset="-120"/>
+              </a:rPr>
+              <a:t>PDF y Word de lo citado, en Descargas, con índice</a:t>
+            </a:r>
+            <a:endParaRPr lang="en-US" sz="1050" dirty="0"/>
+          </a:p>
+        </p:txBody>
+      </p:sp>
+      <p:sp>
+        <p:nvSpPr>
+          <p:cNvPr id="22" name="Text 20"/>
           <p:cNvSpPr/>
           <p:nvPr/>
         </p:nvSpPr>

</xml_diff>